<commit_message>
Workshop-Schlussfolie an Standard angleichen
Die Schlussfolie der vier neuen Präsentationen (Wissensdatenbank,
Bewusstseinstest, Blog, Journal) übernimmt jetzt exakt das Layout der
bestehenden Decks (Vorbild: „Deinen Kopf verstehen"): zentriert in der
unteren Bildhälfte, Titel 40pt mit Akzentwort in Leaf-Grün, Dankzeile
gedämpft (18pt), URL in Teal (14pt, fett). Vorher war der Text links
ausgerichtet, zu weit oben und im falschen Akzentton.

Generator tools/workshop/build.py entsprechend angepasst und alle vier
Foliensätze samt Workbooks/Moderationsplänen neu erzeugt.

Co-Authored-By: Claude Opus 4.8 <noreply@anthropic.com>
Claude-Session: https://claude.ai/code/session_01Y78Cr7oPmigYNqRurKCLqb
</commit_message>
<xml_diff>
--- a/content/vorlagen/workshop/WMDG-Workshop-Bewusstseinstest-Wo-stehst-du.pptx
+++ b/content/vorlagen/workshop/WMDG-Workshop-Bewusstseinstest-Wo-stehst-du.pptx
@@ -8503,8 +8503,8 @@
         </p:nvSpPr>
         <p:spPr>
           <a:xfrm>
-            <a:off x="868680" y="2194560"/>
-            <a:ext cx="10454335" cy="1463040"/>
+            <a:off x="914400" y="3749039"/>
+            <a:ext cx="10360152" cy="914400"/>
           </a:xfrm>
           <a:prstGeom prst="rect">
             <a:avLst/>
@@ -8512,16 +8512,12 @@
           <a:noFill/>
         </p:spPr>
         <p:txBody>
-          <a:bodyPr wrap="square" anchor="ctr" lIns="0" rIns="0" tIns="0" bIns="0">
-            <a:noAutofit/>
-          </a:bodyPr>
-          <a:lstStyle/>
-          <a:p>
-            <a:pPr>
-              <a:lnSpc>
-                <a:spcPct val="105000"/>
-              </a:lnSpc>
-            </a:pPr>
+          <a:bodyPr wrap="square" anchor="t" lIns="0" rIns="0" tIns="0" bIns="0">
+            <a:noAutofit/>
+          </a:bodyPr>
+          <a:lstStyle/>
+          <a:p>
+            <a:pPr algn="ctr"/>
             <a:r>
               <a:rPr sz="4000" b="1" i="0">
                 <a:solidFill>
@@ -8534,7 +8530,7 @@
             <a:r>
               <a:rPr sz="4000" b="1" i="0">
                 <a:solidFill>
-                  <a:srgbClr val="34C4C4"/>
+                  <a:srgbClr val="A3D64F"/>
                 </a:solidFill>
                 <a:latin typeface="Cambria"/>
               </a:rPr>
@@ -8560,8 +8556,8 @@
         </p:nvSpPr>
         <p:spPr>
           <a:xfrm>
-            <a:off x="868680" y="3977639"/>
-            <a:ext cx="10454335" cy="548640"/>
+            <a:off x="914400" y="4754880"/>
+            <a:ext cx="10360152" cy="457200"/>
           </a:xfrm>
           <a:prstGeom prst="rect">
             <a:avLst/>
@@ -8574,10 +8570,11 @@
           </a:bodyPr>
           <a:lstStyle/>
           <a:p>
-            <a:r>
-              <a:rPr sz="1700" b="0" i="0">
-                <a:solidFill>
-                  <a:srgbClr val="D8DBE6"/>
+            <a:pPr algn="ctr"/>
+            <a:r>
+              <a:rPr sz="1800" b="0" i="0">
+                <a:solidFill>
+                  <a:srgbClr val="C3CCDD"/>
                 </a:solidFill>
                 <a:latin typeface="Calibri"/>
               </a:rPr>
@@ -8594,8 +8591,8 @@
         </p:nvSpPr>
         <p:spPr>
           <a:xfrm>
-            <a:off x="868680" y="5989320"/>
-            <a:ext cx="10454335" cy="365760"/>
+            <a:off x="914400" y="5852160"/>
+            <a:ext cx="10360152" cy="365760"/>
           </a:xfrm>
           <a:prstGeom prst="rect">
             <a:avLst/>
@@ -8608,10 +8605,11 @@
           </a:bodyPr>
           <a:lstStyle/>
           <a:p>
-            <a:r>
-              <a:rPr sz="1300" b="0" i="0">
-                <a:solidFill>
-                  <a:srgbClr val="AEB6C6"/>
+            <a:pPr algn="ctr"/>
+            <a:r>
+              <a:rPr sz="1400" b="1" i="0">
+                <a:solidFill>
+                  <a:srgbClr val="34C4C4"/>
                 </a:solidFill>
                 <a:latin typeface="Calibri"/>
               </a:rPr>

</xml_diff>